<commit_message>
adiciona link do site na apresentacao
</commit_message>
<xml_diff>
--- a/docs/APRESENTACAO_FINVIEW_AI.pptx
+++ b/docs/APRESENTACAO_FINVIEW_AI.pptx
@@ -3609,6 +3609,96 @@
             </a:pPr>
             <a:r>
               <a:t>1</a:t>
+            </a:r>
+          </a:p>
+        </p:txBody>
+      </p:sp>
+      <p:sp>
+        <p:nvSpPr>
+          <p:cNvPr id="13" name="Rounded Rectangle 12">
+            <a:hlinkClick r:id="rId2"/>
+          </p:cNvPr>
+          <p:cNvSpPr/>
+          <p:nvPr/>
+        </p:nvSpPr>
+        <p:spPr>
+          <a:xfrm>
+            <a:off x="777240" y="5257800"/>
+            <a:ext cx="4069080" cy="502920"/>
+          </a:xfrm>
+          <a:prstGeom prst="roundRect">
+            <a:avLst/>
+          </a:prstGeom>
+          <a:solidFill>
+            <a:srgbClr val="BE4AEE"/>
+          </a:solidFill>
+          <a:ln>
+            <a:noFill/>
+          </a:ln>
+        </p:spPr>
+        <p:style>
+          <a:lnRef idx="1">
+            <a:schemeClr val="accent1"/>
+          </a:lnRef>
+          <a:fillRef idx="3">
+            <a:schemeClr val="accent1"/>
+          </a:fillRef>
+          <a:effectRef idx="2">
+            <a:schemeClr val="accent1"/>
+          </a:effectRef>
+          <a:fontRef idx="minor">
+            <a:schemeClr val="lt1"/>
+          </a:fontRef>
+        </p:style>
+        <p:txBody>
+          <a:bodyPr rtlCol="0" anchor="ctr" lIns="146304" rIns="146304"/>
+          <a:lstStyle/>
+          <a:p>
+            <a:pPr algn="ctr"/>
+            <a:r>
+              <a:rPr sz="1500" b="1">
+                <a:solidFill>
+                  <a:srgbClr val="12081F"/>
+                </a:solidFill>
+                <a:latin typeface="Aptos"/>
+              </a:rPr>
+              <a:t>Acessar site em produção</a:t>
+            </a:r>
+          </a:p>
+        </p:txBody>
+      </p:sp>
+      <p:sp>
+        <p:nvSpPr>
+          <p:cNvPr id="14" name="TextBox 13"/>
+          <p:cNvSpPr txBox="1"/>
+          <p:nvPr/>
+        </p:nvSpPr>
+        <p:spPr>
+          <a:xfrm>
+            <a:off x="795528" y="5833872"/>
+            <a:ext cx="6126480" cy="228600"/>
+          </a:xfrm>
+          <a:prstGeom prst="rect">
+            <a:avLst/>
+          </a:prstGeom>
+          <a:noFill/>
+        </p:spPr>
+        <p:txBody>
+          <a:bodyPr wrap="none">
+            <a:spAutoFit/>
+          </a:bodyPr>
+          <a:lstStyle/>
+          <a:p>
+            <a:pPr algn="l"/>
+            <a:r>
+              <a:rPr sz="1000">
+                <a:solidFill>
+                  <a:srgbClr val="C5B8D7"/>
+                </a:solidFill>
+                <a:latin typeface="Aptos"/>
+                <a:hlinkClick r:id="rId2"/>
+              </a:rPr>
+              <a:t>https://finview-hqws.onrender.com/dashboard/</a:t>
             </a:r>
           </a:p>
         </p:txBody>

</xml_diff>